<commit_message>
add: xmind and usecase of inflow system
</commit_message>
<xml_diff>
--- a/Document/Presentation/inFlowManufacturing.pptx
+++ b/Document/Presentation/inFlowManufacturing.pptx
@@ -10,10 +10,16 @@
     <p:sldId id="258" r:id="rId4"/>
     <p:sldId id="259" r:id="rId5"/>
     <p:sldId id="260" r:id="rId6"/>
-    <p:sldId id="261" r:id="rId7"/>
-    <p:sldId id="262" r:id="rId8"/>
-    <p:sldId id="263" r:id="rId9"/>
-    <p:sldId id="264" r:id="rId10"/>
+    <p:sldId id="262" r:id="rId7"/>
+    <p:sldId id="263" r:id="rId8"/>
+    <p:sldId id="264" r:id="rId9"/>
+    <p:sldId id="265" r:id="rId10"/>
+    <p:sldId id="266" r:id="rId11"/>
+    <p:sldId id="267" r:id="rId12"/>
+    <p:sldId id="268" r:id="rId13"/>
+    <p:sldId id="269" r:id="rId14"/>
+    <p:sldId id="270" r:id="rId15"/>
+    <p:sldId id="271" r:id="rId16"/>
   </p:sldIdLst>
   <p:sldSz cx="12192000" cy="6858000"/>
   <p:notesSz cx="6858000" cy="9144000"/>
@@ -120,7 +126,7 @@
             <a:srgbClr val="A4A3A4"/>
           </p15:clr>
         </p15:guide>
-        <p15:guide id="2" pos="3840" userDrawn="1">
+        <p15:guide id="2" pos="3864" userDrawn="1">
           <p15:clr>
             <a:srgbClr val="A4A3A4"/>
           </p15:clr>
@@ -3388,6 +3394,598 @@
 </p:sld>
 </file>
 
+<file path=ppt/slides/slide10.xml><?xml version="1.0" encoding="utf-8"?>
+<p:sld xmlns:a="http://schemas.openxmlformats.org/drawingml/2006/main" xmlns:r="http://schemas.openxmlformats.org/officeDocument/2006/relationships" xmlns:p="http://schemas.openxmlformats.org/presentationml/2006/main">
+  <p:cSld>
+    <p:spTree>
+      <p:nvGrpSpPr>
+        <p:cNvPr id="1" name=""/>
+        <p:cNvGrpSpPr/>
+        <p:nvPr/>
+      </p:nvGrpSpPr>
+      <p:grpSpPr>
+        <a:xfrm>
+          <a:off x="0" y="0"/>
+          <a:ext cx="0" cy="0"/>
+          <a:chOff x="0" y="0"/>
+          <a:chExt cx="0" cy="0"/>
+        </a:xfrm>
+      </p:grpSpPr>
+      <p:sp>
+        <p:nvSpPr>
+          <p:cNvPr id="14" name="Title 13">
+            <a:extLst>
+              <a:ext uri="{FF2B5EF4-FFF2-40B4-BE49-F238E27FC236}">
+                <a16:creationId xmlns:a16="http://schemas.microsoft.com/office/drawing/2014/main" id="{7F9AD821-9136-43E7-65A3-316A7456E78F}"/>
+              </a:ext>
+            </a:extLst>
+          </p:cNvPr>
+          <p:cNvSpPr>
+            <a:spLocks noGrp="1"/>
+          </p:cNvSpPr>
+          <p:nvPr>
+            <p:ph type="title"/>
+          </p:nvPr>
+        </p:nvSpPr>
+        <p:spPr/>
+        <p:txBody>
+          <a:bodyPr/>
+          <a:lstStyle/>
+          <a:p>
+            <a:r>
+              <a:rPr lang="en-US" b="0" i="0" u="none" strike="noStrike" dirty="0">
+                <a:solidFill>
+                  <a:srgbClr val="58698D"/>
+                </a:solidFill>
+                <a:effectLst/>
+                <a:latin typeface="Lato" panose="020F0502020204030203" pitchFamily="34" charset="0"/>
+              </a:rPr>
+              <a:t>Location</a:t>
+            </a:r>
+            <a:endParaRPr lang="en-US" dirty="0"/>
+          </a:p>
+        </p:txBody>
+      </p:sp>
+      <p:pic>
+        <p:nvPicPr>
+          <p:cNvPr id="4" name="Picture 3">
+            <a:extLst>
+              <a:ext uri="{FF2B5EF4-FFF2-40B4-BE49-F238E27FC236}">
+                <a16:creationId xmlns:a16="http://schemas.microsoft.com/office/drawing/2014/main" id="{54B19D6D-672C-7DD0-3620-819AFAF31CDC}"/>
+              </a:ext>
+            </a:extLst>
+          </p:cNvPr>
+          <p:cNvPicPr>
+            <a:picLocks noChangeAspect="1"/>
+          </p:cNvPicPr>
+          <p:nvPr/>
+        </p:nvPicPr>
+        <p:blipFill>
+          <a:blip r:embed="rId2"/>
+          <a:stretch>
+            <a:fillRect/>
+          </a:stretch>
+        </p:blipFill>
+        <p:spPr>
+          <a:xfrm>
+            <a:off x="838200" y="1462088"/>
+            <a:ext cx="3342735" cy="5167312"/>
+          </a:xfrm>
+          <a:prstGeom prst="rect">
+            <a:avLst/>
+          </a:prstGeom>
+        </p:spPr>
+      </p:pic>
+    </p:spTree>
+    <p:extLst>
+      <p:ext uri="{BB962C8B-B14F-4D97-AF65-F5344CB8AC3E}">
+        <p14:creationId xmlns:p14="http://schemas.microsoft.com/office/powerpoint/2010/main" val="1951388281"/>
+      </p:ext>
+    </p:extLst>
+  </p:cSld>
+  <p:clrMapOvr>
+    <a:masterClrMapping/>
+  </p:clrMapOvr>
+</p:sld>
+</file>
+
+<file path=ppt/slides/slide11.xml><?xml version="1.0" encoding="utf-8"?>
+<p:sld xmlns:a="http://schemas.openxmlformats.org/drawingml/2006/main" xmlns:r="http://schemas.openxmlformats.org/officeDocument/2006/relationships" xmlns:p="http://schemas.openxmlformats.org/presentationml/2006/main">
+  <p:cSld>
+    <p:spTree>
+      <p:nvGrpSpPr>
+        <p:cNvPr id="1" name=""/>
+        <p:cNvGrpSpPr/>
+        <p:nvPr/>
+      </p:nvGrpSpPr>
+      <p:grpSpPr>
+        <a:xfrm>
+          <a:off x="0" y="0"/>
+          <a:ext cx="0" cy="0"/>
+          <a:chOff x="0" y="0"/>
+          <a:chExt cx="0" cy="0"/>
+        </a:xfrm>
+      </p:grpSpPr>
+      <p:sp>
+        <p:nvSpPr>
+          <p:cNvPr id="14" name="Title 13">
+            <a:extLst>
+              <a:ext uri="{FF2B5EF4-FFF2-40B4-BE49-F238E27FC236}">
+                <a16:creationId xmlns:a16="http://schemas.microsoft.com/office/drawing/2014/main" id="{7F9AD821-9136-43E7-65A3-316A7456E78F}"/>
+              </a:ext>
+            </a:extLst>
+          </p:cNvPr>
+          <p:cNvSpPr>
+            <a:spLocks noGrp="1"/>
+          </p:cNvSpPr>
+          <p:nvPr>
+            <p:ph type="title"/>
+          </p:nvPr>
+        </p:nvSpPr>
+        <p:spPr/>
+        <p:txBody>
+          <a:bodyPr/>
+          <a:lstStyle/>
+          <a:p>
+            <a:r>
+              <a:rPr lang="en-US" b="0" i="0" u="none" strike="noStrike" dirty="0">
+                <a:solidFill>
+                  <a:srgbClr val="58698D"/>
+                </a:solidFill>
+                <a:effectLst/>
+                <a:latin typeface="Lato" panose="020F0502020204030203" pitchFamily="34" charset="0"/>
+              </a:rPr>
+              <a:t>Product Categories</a:t>
+            </a:r>
+            <a:endParaRPr lang="en-US" dirty="0"/>
+          </a:p>
+        </p:txBody>
+      </p:sp>
+      <p:pic>
+        <p:nvPicPr>
+          <p:cNvPr id="3" name="Picture 2">
+            <a:extLst>
+              <a:ext uri="{FF2B5EF4-FFF2-40B4-BE49-F238E27FC236}">
+                <a16:creationId xmlns:a16="http://schemas.microsoft.com/office/drawing/2014/main" id="{D1BAA05D-274A-3949-C0A9-791A7093F032}"/>
+              </a:ext>
+            </a:extLst>
+          </p:cNvPr>
+          <p:cNvPicPr>
+            <a:picLocks noChangeAspect="1"/>
+          </p:cNvPicPr>
+          <p:nvPr/>
+        </p:nvPicPr>
+        <p:blipFill>
+          <a:blip r:embed="rId2"/>
+          <a:stretch>
+            <a:fillRect/>
+          </a:stretch>
+        </p:blipFill>
+        <p:spPr>
+          <a:xfrm>
+            <a:off x="7665490" y="0"/>
+            <a:ext cx="3414220" cy="6858000"/>
+          </a:xfrm>
+          <a:prstGeom prst="rect">
+            <a:avLst/>
+          </a:prstGeom>
+        </p:spPr>
+      </p:pic>
+    </p:spTree>
+    <p:extLst>
+      <p:ext uri="{BB962C8B-B14F-4D97-AF65-F5344CB8AC3E}">
+        <p14:creationId xmlns:p14="http://schemas.microsoft.com/office/powerpoint/2010/main" val="3651362054"/>
+      </p:ext>
+    </p:extLst>
+  </p:cSld>
+  <p:clrMapOvr>
+    <a:masterClrMapping/>
+  </p:clrMapOvr>
+</p:sld>
+</file>
+
+<file path=ppt/slides/slide12.xml><?xml version="1.0" encoding="utf-8"?>
+<p:sld xmlns:a="http://schemas.openxmlformats.org/drawingml/2006/main" xmlns:r="http://schemas.openxmlformats.org/officeDocument/2006/relationships" xmlns:p="http://schemas.openxmlformats.org/presentationml/2006/main">
+  <p:cSld>
+    <p:spTree>
+      <p:nvGrpSpPr>
+        <p:cNvPr id="1" name=""/>
+        <p:cNvGrpSpPr/>
+        <p:nvPr/>
+      </p:nvGrpSpPr>
+      <p:grpSpPr>
+        <a:xfrm>
+          <a:off x="0" y="0"/>
+          <a:ext cx="0" cy="0"/>
+          <a:chOff x="0" y="0"/>
+          <a:chExt cx="0" cy="0"/>
+        </a:xfrm>
+      </p:grpSpPr>
+      <p:sp>
+        <p:nvSpPr>
+          <p:cNvPr id="14" name="Title 13">
+            <a:extLst>
+              <a:ext uri="{FF2B5EF4-FFF2-40B4-BE49-F238E27FC236}">
+                <a16:creationId xmlns:a16="http://schemas.microsoft.com/office/drawing/2014/main" id="{7F9AD821-9136-43E7-65A3-316A7456E78F}"/>
+              </a:ext>
+            </a:extLst>
+          </p:cNvPr>
+          <p:cNvSpPr>
+            <a:spLocks noGrp="1"/>
+          </p:cNvSpPr>
+          <p:nvPr>
+            <p:ph type="title"/>
+          </p:nvPr>
+        </p:nvSpPr>
+        <p:spPr/>
+        <p:txBody>
+          <a:bodyPr/>
+          <a:lstStyle/>
+          <a:p>
+            <a:r>
+              <a:rPr lang="en-US" dirty="0">
+                <a:solidFill>
+                  <a:srgbClr val="58698D"/>
+                </a:solidFill>
+                <a:latin typeface="Lato" panose="020F0502020204030203" pitchFamily="34" charset="0"/>
+              </a:rPr>
+              <a:t>Adjustment Reasons</a:t>
+            </a:r>
+            <a:endParaRPr lang="en-US" dirty="0"/>
+          </a:p>
+        </p:txBody>
+      </p:sp>
+      <p:pic>
+        <p:nvPicPr>
+          <p:cNvPr id="8" name="Picture 7">
+            <a:extLst>
+              <a:ext uri="{FF2B5EF4-FFF2-40B4-BE49-F238E27FC236}">
+                <a16:creationId xmlns:a16="http://schemas.microsoft.com/office/drawing/2014/main" id="{0AE51B69-6D6B-A15A-6BB1-13AFEC52142B}"/>
+              </a:ext>
+            </a:extLst>
+          </p:cNvPr>
+          <p:cNvPicPr>
+            <a:picLocks noChangeAspect="1"/>
+          </p:cNvPicPr>
+          <p:nvPr/>
+        </p:nvPicPr>
+        <p:blipFill>
+          <a:blip r:embed="rId2"/>
+          <a:stretch>
+            <a:fillRect/>
+          </a:stretch>
+        </p:blipFill>
+        <p:spPr>
+          <a:xfrm>
+            <a:off x="838200" y="1690688"/>
+            <a:ext cx="4667901" cy="3886742"/>
+          </a:xfrm>
+          <a:prstGeom prst="rect">
+            <a:avLst/>
+          </a:prstGeom>
+        </p:spPr>
+      </p:pic>
+    </p:spTree>
+    <p:extLst>
+      <p:ext uri="{BB962C8B-B14F-4D97-AF65-F5344CB8AC3E}">
+        <p14:creationId xmlns:p14="http://schemas.microsoft.com/office/powerpoint/2010/main" val="3138973822"/>
+      </p:ext>
+    </p:extLst>
+  </p:cSld>
+  <p:clrMapOvr>
+    <a:masterClrMapping/>
+  </p:clrMapOvr>
+</p:sld>
+</file>
+
+<file path=ppt/slides/slide13.xml><?xml version="1.0" encoding="utf-8"?>
+<p:sld xmlns:a="http://schemas.openxmlformats.org/drawingml/2006/main" xmlns:r="http://schemas.openxmlformats.org/officeDocument/2006/relationships" xmlns:p="http://schemas.openxmlformats.org/presentationml/2006/main">
+  <p:cSld>
+    <p:spTree>
+      <p:nvGrpSpPr>
+        <p:cNvPr id="1" name=""/>
+        <p:cNvGrpSpPr/>
+        <p:nvPr/>
+      </p:nvGrpSpPr>
+      <p:grpSpPr>
+        <a:xfrm>
+          <a:off x="0" y="0"/>
+          <a:ext cx="0" cy="0"/>
+          <a:chOff x="0" y="0"/>
+          <a:chExt cx="0" cy="0"/>
+        </a:xfrm>
+      </p:grpSpPr>
+      <p:sp>
+        <p:nvSpPr>
+          <p:cNvPr id="14" name="Title 13">
+            <a:extLst>
+              <a:ext uri="{FF2B5EF4-FFF2-40B4-BE49-F238E27FC236}">
+                <a16:creationId xmlns:a16="http://schemas.microsoft.com/office/drawing/2014/main" id="{7F9AD821-9136-43E7-65A3-316A7456E78F}"/>
+              </a:ext>
+            </a:extLst>
+          </p:cNvPr>
+          <p:cNvSpPr>
+            <a:spLocks noGrp="1"/>
+          </p:cNvSpPr>
+          <p:nvPr>
+            <p:ph type="title"/>
+          </p:nvPr>
+        </p:nvSpPr>
+        <p:spPr/>
+        <p:txBody>
+          <a:bodyPr/>
+          <a:lstStyle/>
+          <a:p>
+            <a:r>
+              <a:rPr lang="en-US" b="0" i="0" u="none" strike="noStrike" dirty="0">
+                <a:solidFill>
+                  <a:srgbClr val="58698D"/>
+                </a:solidFill>
+                <a:effectLst/>
+                <a:latin typeface="Lato" panose="020F0502020204030203" pitchFamily="34" charset="0"/>
+              </a:rPr>
+              <a:t>Unit of measurement</a:t>
+            </a:r>
+            <a:endParaRPr lang="en-US" dirty="0"/>
+          </a:p>
+        </p:txBody>
+      </p:sp>
+      <p:pic>
+        <p:nvPicPr>
+          <p:cNvPr id="3" name="Picture 2">
+            <a:extLst>
+              <a:ext uri="{FF2B5EF4-FFF2-40B4-BE49-F238E27FC236}">
+                <a16:creationId xmlns:a16="http://schemas.microsoft.com/office/drawing/2014/main" id="{54049DAB-9126-3BA5-68EC-68101F3010C7}"/>
+              </a:ext>
+            </a:extLst>
+          </p:cNvPr>
+          <p:cNvPicPr>
+            <a:picLocks noChangeAspect="1"/>
+          </p:cNvPicPr>
+          <p:nvPr/>
+        </p:nvPicPr>
+        <p:blipFill>
+          <a:blip r:embed="rId2"/>
+          <a:stretch>
+            <a:fillRect/>
+          </a:stretch>
+        </p:blipFill>
+        <p:spPr>
+          <a:xfrm>
+            <a:off x="838200" y="1574800"/>
+            <a:ext cx="2736945" cy="5283200"/>
+          </a:xfrm>
+          <a:prstGeom prst="rect">
+            <a:avLst/>
+          </a:prstGeom>
+        </p:spPr>
+      </p:pic>
+      <p:pic>
+        <p:nvPicPr>
+          <p:cNvPr id="5" name="Picture 4">
+            <a:extLst>
+              <a:ext uri="{FF2B5EF4-FFF2-40B4-BE49-F238E27FC236}">
+                <a16:creationId xmlns:a16="http://schemas.microsoft.com/office/drawing/2014/main" id="{E73E3A54-7B2D-CEF7-BECE-75EF9D6E67B5}"/>
+              </a:ext>
+            </a:extLst>
+          </p:cNvPr>
+          <p:cNvPicPr>
+            <a:picLocks noChangeAspect="1"/>
+          </p:cNvPicPr>
+          <p:nvPr/>
+        </p:nvPicPr>
+        <p:blipFill>
+          <a:blip r:embed="rId3"/>
+          <a:stretch>
+            <a:fillRect/>
+          </a:stretch>
+        </p:blipFill>
+        <p:spPr>
+          <a:xfrm>
+            <a:off x="7398050" y="1574800"/>
+            <a:ext cx="2709624" cy="5283200"/>
+          </a:xfrm>
+          <a:prstGeom prst="rect">
+            <a:avLst/>
+          </a:prstGeom>
+        </p:spPr>
+      </p:pic>
+    </p:spTree>
+    <p:extLst>
+      <p:ext uri="{BB962C8B-B14F-4D97-AF65-F5344CB8AC3E}">
+        <p14:creationId xmlns:p14="http://schemas.microsoft.com/office/powerpoint/2010/main" val="1879376407"/>
+      </p:ext>
+    </p:extLst>
+  </p:cSld>
+  <p:clrMapOvr>
+    <a:masterClrMapping/>
+  </p:clrMapOvr>
+</p:sld>
+</file>
+
+<file path=ppt/slides/slide14.xml><?xml version="1.0" encoding="utf-8"?>
+<p:sld xmlns:a="http://schemas.openxmlformats.org/drawingml/2006/main" xmlns:r="http://schemas.openxmlformats.org/officeDocument/2006/relationships" xmlns:p="http://schemas.openxmlformats.org/presentationml/2006/main">
+  <p:cSld>
+    <p:spTree>
+      <p:nvGrpSpPr>
+        <p:cNvPr id="1" name=""/>
+        <p:cNvGrpSpPr/>
+        <p:nvPr/>
+      </p:nvGrpSpPr>
+      <p:grpSpPr>
+        <a:xfrm>
+          <a:off x="0" y="0"/>
+          <a:ext cx="0" cy="0"/>
+          <a:chOff x="0" y="0"/>
+          <a:chExt cx="0" cy="0"/>
+        </a:xfrm>
+      </p:grpSpPr>
+      <p:sp>
+        <p:nvSpPr>
+          <p:cNvPr id="14" name="Title 13">
+            <a:extLst>
+              <a:ext uri="{FF2B5EF4-FFF2-40B4-BE49-F238E27FC236}">
+                <a16:creationId xmlns:a16="http://schemas.microsoft.com/office/drawing/2014/main" id="{7F9AD821-9136-43E7-65A3-316A7456E78F}"/>
+              </a:ext>
+            </a:extLst>
+          </p:cNvPr>
+          <p:cNvSpPr>
+            <a:spLocks noGrp="1"/>
+          </p:cNvSpPr>
+          <p:nvPr>
+            <p:ph type="title"/>
+          </p:nvPr>
+        </p:nvSpPr>
+        <p:spPr/>
+        <p:txBody>
+          <a:bodyPr/>
+          <a:lstStyle/>
+          <a:p>
+            <a:r>
+              <a:rPr lang="en-US" b="0" i="0" u="none" strike="noStrike" dirty="0">
+                <a:solidFill>
+                  <a:srgbClr val="58698D"/>
+                </a:solidFill>
+                <a:effectLst/>
+                <a:latin typeface="Lato" panose="020F0502020204030203" pitchFamily="34" charset="0"/>
+              </a:rPr>
+              <a:t>SKUs</a:t>
+            </a:r>
+            <a:endParaRPr lang="en-US" dirty="0"/>
+          </a:p>
+        </p:txBody>
+      </p:sp>
+      <p:pic>
+        <p:nvPicPr>
+          <p:cNvPr id="4" name="Picture 3">
+            <a:extLst>
+              <a:ext uri="{FF2B5EF4-FFF2-40B4-BE49-F238E27FC236}">
+                <a16:creationId xmlns:a16="http://schemas.microsoft.com/office/drawing/2014/main" id="{EE13A35C-7766-989E-3240-F2D5DB1F595B}"/>
+              </a:ext>
+            </a:extLst>
+          </p:cNvPr>
+          <p:cNvPicPr>
+            <a:picLocks noChangeAspect="1"/>
+          </p:cNvPicPr>
+          <p:nvPr/>
+        </p:nvPicPr>
+        <p:blipFill>
+          <a:blip r:embed="rId2"/>
+          <a:stretch>
+            <a:fillRect/>
+          </a:stretch>
+        </p:blipFill>
+        <p:spPr>
+          <a:xfrm>
+            <a:off x="838200" y="1690688"/>
+            <a:ext cx="4544059" cy="4467849"/>
+          </a:xfrm>
+          <a:prstGeom prst="rect">
+            <a:avLst/>
+          </a:prstGeom>
+        </p:spPr>
+      </p:pic>
+    </p:spTree>
+    <p:extLst>
+      <p:ext uri="{BB962C8B-B14F-4D97-AF65-F5344CB8AC3E}">
+        <p14:creationId xmlns:p14="http://schemas.microsoft.com/office/powerpoint/2010/main" val="435222043"/>
+      </p:ext>
+    </p:extLst>
+  </p:cSld>
+  <p:clrMapOvr>
+    <a:masterClrMapping/>
+  </p:clrMapOvr>
+</p:sld>
+</file>
+
+<file path=ppt/slides/slide15.xml><?xml version="1.0" encoding="utf-8"?>
+<p:sld xmlns:a="http://schemas.openxmlformats.org/drawingml/2006/main" xmlns:r="http://schemas.openxmlformats.org/officeDocument/2006/relationships" xmlns:p="http://schemas.openxmlformats.org/presentationml/2006/main">
+  <p:cSld>
+    <p:spTree>
+      <p:nvGrpSpPr>
+        <p:cNvPr id="1" name=""/>
+        <p:cNvGrpSpPr/>
+        <p:nvPr/>
+      </p:nvGrpSpPr>
+      <p:grpSpPr>
+        <a:xfrm>
+          <a:off x="0" y="0"/>
+          <a:ext cx="0" cy="0"/>
+          <a:chOff x="0" y="0"/>
+          <a:chExt cx="0" cy="0"/>
+        </a:xfrm>
+      </p:grpSpPr>
+      <p:sp>
+        <p:nvSpPr>
+          <p:cNvPr id="2" name="Title 1">
+            <a:extLst>
+              <a:ext uri="{FF2B5EF4-FFF2-40B4-BE49-F238E27FC236}">
+                <a16:creationId xmlns:a16="http://schemas.microsoft.com/office/drawing/2014/main" id="{1888FAA8-8C74-0133-CE17-746FE12011DB}"/>
+              </a:ext>
+            </a:extLst>
+          </p:cNvPr>
+          <p:cNvSpPr>
+            <a:spLocks noGrp="1"/>
+          </p:cNvSpPr>
+          <p:nvPr>
+            <p:ph type="title"/>
+          </p:nvPr>
+        </p:nvSpPr>
+        <p:spPr/>
+        <p:txBody>
+          <a:bodyPr/>
+          <a:lstStyle/>
+          <a:p>
+            <a:r>
+              <a:rPr lang="en-US" dirty="0"/>
+              <a:t>Label</a:t>
+            </a:r>
+          </a:p>
+        </p:txBody>
+      </p:sp>
+      <p:pic>
+        <p:nvPicPr>
+          <p:cNvPr id="4" name="Picture 3">
+            <a:extLst>
+              <a:ext uri="{FF2B5EF4-FFF2-40B4-BE49-F238E27FC236}">
+                <a16:creationId xmlns:a16="http://schemas.microsoft.com/office/drawing/2014/main" id="{6AB88B86-65EC-7CCD-F198-C7C536E1085A}"/>
+              </a:ext>
+            </a:extLst>
+          </p:cNvPr>
+          <p:cNvPicPr>
+            <a:picLocks noChangeAspect="1"/>
+          </p:cNvPicPr>
+          <p:nvPr/>
+        </p:nvPicPr>
+        <p:blipFill>
+          <a:blip r:embed="rId2"/>
+          <a:stretch>
+            <a:fillRect/>
+          </a:stretch>
+        </p:blipFill>
+        <p:spPr>
+          <a:xfrm>
+            <a:off x="838200" y="1953546"/>
+            <a:ext cx="9425031" cy="4904454"/>
+          </a:xfrm>
+          <a:prstGeom prst="rect">
+            <a:avLst/>
+          </a:prstGeom>
+        </p:spPr>
+      </p:pic>
+    </p:spTree>
+    <p:extLst>
+      <p:ext uri="{BB962C8B-B14F-4D97-AF65-F5344CB8AC3E}">
+        <p14:creationId xmlns:p14="http://schemas.microsoft.com/office/powerpoint/2010/main" val="1023259903"/>
+      </p:ext>
+    </p:extLst>
+  </p:cSld>
+  <p:clrMapOvr>
+    <a:masterClrMapping/>
+  </p:clrMapOvr>
+</p:sld>
+</file>
+
 <file path=ppt/slides/slide2.xml><?xml version="1.0" encoding="utf-8"?>
 <p:sld xmlns:a="http://schemas.openxmlformats.org/drawingml/2006/main" xmlns:r="http://schemas.openxmlformats.org/officeDocument/2006/relationships" xmlns:p="http://schemas.openxmlformats.org/presentationml/2006/main">
   <p:cSld>
@@ -3405,12 +4003,42 @@
           <a:chExt cx="0" cy="0"/>
         </a:xfrm>
       </p:grpSpPr>
-      <p:sp>
-        <p:nvSpPr>
-          <p:cNvPr id="2" name="Title 1">
-            <a:extLst>
-              <a:ext uri="{FF2B5EF4-FFF2-40B4-BE49-F238E27FC236}">
-                <a16:creationId xmlns:a16="http://schemas.microsoft.com/office/drawing/2014/main" id="{44B5E3D5-6A34-F4BC-D40E-19DF4BE353E6}"/>
+      <p:pic>
+        <p:nvPicPr>
+          <p:cNvPr id="3" name="Picture 2">
+            <a:extLst>
+              <a:ext uri="{FF2B5EF4-FFF2-40B4-BE49-F238E27FC236}">
+                <a16:creationId xmlns:a16="http://schemas.microsoft.com/office/drawing/2014/main" id="{79D035CB-5302-1D54-2E7D-0A4C9CCA6EBE}"/>
+              </a:ext>
+            </a:extLst>
+          </p:cNvPr>
+          <p:cNvPicPr>
+            <a:picLocks noChangeAspect="1"/>
+          </p:cNvPicPr>
+          <p:nvPr/>
+        </p:nvPicPr>
+        <p:blipFill>
+          <a:blip r:embed="rId2"/>
+          <a:stretch>
+            <a:fillRect/>
+          </a:stretch>
+        </p:blipFill>
+        <p:spPr>
+          <a:xfrm>
+            <a:off x="3952570" y="1717430"/>
+            <a:ext cx="4363059" cy="4810796"/>
+          </a:xfrm>
+          <a:prstGeom prst="rect">
+            <a:avLst/>
+          </a:prstGeom>
+        </p:spPr>
+      </p:pic>
+      <p:sp>
+        <p:nvSpPr>
+          <p:cNvPr id="4" name="Title 3">
+            <a:extLst>
+              <a:ext uri="{FF2B5EF4-FFF2-40B4-BE49-F238E27FC236}">
+                <a16:creationId xmlns:a16="http://schemas.microsoft.com/office/drawing/2014/main" id="{AD261F1B-ABF6-11E5-10D4-B29410118DE6}"/>
               </a:ext>
             </a:extLst>
           </p:cNvPr>
@@ -3426,39 +4054,17 @@
           <a:bodyPr/>
           <a:lstStyle/>
           <a:p>
-            <a:endParaRPr lang="en-US"/>
-          </a:p>
-        </p:txBody>
-      </p:sp>
-      <p:sp>
-        <p:nvSpPr>
-          <p:cNvPr id="3" name="Content Placeholder 2">
-            <a:extLst>
-              <a:ext uri="{FF2B5EF4-FFF2-40B4-BE49-F238E27FC236}">
-                <a16:creationId xmlns:a16="http://schemas.microsoft.com/office/drawing/2014/main" id="{119F5501-CD80-CA9B-AE8A-939EE41D7B1A}"/>
-              </a:ext>
-            </a:extLst>
-          </p:cNvPr>
-          <p:cNvSpPr>
-            <a:spLocks noGrp="1"/>
-          </p:cNvSpPr>
-          <p:nvPr>
-            <p:ph idx="1"/>
-          </p:nvPr>
-        </p:nvSpPr>
-        <p:spPr/>
-        <p:txBody>
-          <a:bodyPr/>
-          <a:lstStyle/>
-          <a:p>
-            <a:endParaRPr lang="en-US"/>
+            <a:r>
+              <a:rPr lang="en-US" dirty="0"/>
+              <a:t>Add New MO</a:t>
+            </a:r>
           </a:p>
         </p:txBody>
       </p:sp>
     </p:spTree>
     <p:extLst>
       <p:ext uri="{BB962C8B-B14F-4D97-AF65-F5344CB8AC3E}">
-        <p14:creationId xmlns:p14="http://schemas.microsoft.com/office/powerpoint/2010/main" val="2060350461"/>
+        <p14:creationId xmlns:p14="http://schemas.microsoft.com/office/powerpoint/2010/main" val="3489661569"/>
       </p:ext>
     </p:extLst>
   </p:cSld>
@@ -3471,6 +4077,14 @@
 <file path=ppt/slides/slide3.xml><?xml version="1.0" encoding="utf-8"?>
 <p:sld xmlns:a="http://schemas.openxmlformats.org/drawingml/2006/main" xmlns:r="http://schemas.openxmlformats.org/officeDocument/2006/relationships" xmlns:p="http://schemas.openxmlformats.org/presentationml/2006/main">
   <p:cSld>
+    <p:bg>
+      <p:bgPr>
+        <a:solidFill>
+          <a:schemeClr val="bg1"/>
+        </a:solidFill>
+        <a:effectLst/>
+      </p:bgPr>
+    </p:bg>
     <p:spTree>
       <p:nvGrpSpPr>
         <p:cNvPr id="1" name=""/>
@@ -3487,58 +4101,372 @@
       </p:grpSpPr>
       <p:sp>
         <p:nvSpPr>
-          <p:cNvPr id="2" name="Title 1">
-            <a:extLst>
-              <a:ext uri="{FF2B5EF4-FFF2-40B4-BE49-F238E27FC236}">
-                <a16:creationId xmlns:a16="http://schemas.microsoft.com/office/drawing/2014/main" id="{44B5E3D5-6A34-F4BC-D40E-19DF4BE353E6}"/>
-              </a:ext>
-            </a:extLst>
-          </p:cNvPr>
-          <p:cNvSpPr>
-            <a:spLocks noGrp="1"/>
-          </p:cNvSpPr>
-          <p:nvPr>
-            <p:ph type="title"/>
-          </p:nvPr>
-        </p:nvSpPr>
-        <p:spPr/>
-        <p:txBody>
-          <a:bodyPr/>
-          <a:lstStyle/>
-          <a:p>
+          <p:cNvPr id="17" name="Rectangle 16">
+            <a:extLst>
+              <a:ext uri="{FF2B5EF4-FFF2-40B4-BE49-F238E27FC236}">
+                <a16:creationId xmlns:a16="http://schemas.microsoft.com/office/drawing/2014/main" id="{9527FCEA-6143-4C5E-8C45-8AC9237ADE89}"/>
+              </a:ext>
+              <a:ext uri="{C183D7F6-B498-43B3-948B-1728B52AA6E4}">
+                <adec:decorative xmlns:adec="http://schemas.microsoft.com/office/drawing/2017/decorative" val="1"/>
+              </a:ext>
+            </a:extLst>
+          </p:cNvPr>
+          <p:cNvSpPr>
+            <a:spLocks noGrp="1" noRot="1" noChangeAspect="1" noMove="1" noResize="1" noEditPoints="1" noAdjustHandles="1" noChangeArrowheads="1" noChangeShapeType="1" noTextEdit="1"/>
+          </p:cNvSpPr>
+          <p:nvPr>
+            <p:extLst>
+              <p:ext uri="{386F3935-93C4-4BCD-93E2-E3B085C9AB24}">
+                <p16:designElem xmlns:p16="http://schemas.microsoft.com/office/powerpoint/2015/main" val="1"/>
+              </p:ext>
+            </p:extLst>
+          </p:nvPr>
+        </p:nvSpPr>
+        <p:spPr>
+          <a:xfrm>
+            <a:off x="0" y="0"/>
+            <a:ext cx="12192000" cy="6858000"/>
+          </a:xfrm>
+          <a:prstGeom prst="rect">
+            <a:avLst/>
+          </a:prstGeom>
+          <a:solidFill>
+            <a:schemeClr val="tx1">
+              <a:lumMod val="50000"/>
+              <a:lumOff val="50000"/>
+              <a:alpha val="30000"/>
+            </a:schemeClr>
+          </a:solidFill>
+          <a:ln>
+            <a:noFill/>
+          </a:ln>
+        </p:spPr>
+        <p:style>
+          <a:lnRef idx="2">
+            <a:schemeClr val="accent1">
+              <a:shade val="50000"/>
+            </a:schemeClr>
+          </a:lnRef>
+          <a:fillRef idx="1">
+            <a:schemeClr val="accent1"/>
+          </a:fillRef>
+          <a:effectRef idx="0">
+            <a:schemeClr val="accent1"/>
+          </a:effectRef>
+          <a:fontRef idx="minor">
+            <a:schemeClr val="lt1"/>
+          </a:fontRef>
+        </p:style>
+        <p:txBody>
+          <a:bodyPr rtlCol="0" anchor="ctr"/>
+          <a:lstStyle/>
+          <a:p>
+            <a:pPr algn="ctr"/>
             <a:endParaRPr lang="en-US"/>
           </a:p>
         </p:txBody>
       </p:sp>
       <p:sp>
         <p:nvSpPr>
-          <p:cNvPr id="3" name="Content Placeholder 2">
-            <a:extLst>
-              <a:ext uri="{FF2B5EF4-FFF2-40B4-BE49-F238E27FC236}">
-                <a16:creationId xmlns:a16="http://schemas.microsoft.com/office/drawing/2014/main" id="{119F5501-CD80-CA9B-AE8A-939EE41D7B1A}"/>
-              </a:ext>
-            </a:extLst>
-          </p:cNvPr>
-          <p:cNvSpPr>
-            <a:spLocks noGrp="1"/>
-          </p:cNvSpPr>
-          <p:nvPr>
-            <p:ph idx="1"/>
-          </p:nvPr>
-        </p:nvSpPr>
-        <p:spPr/>
-        <p:txBody>
-          <a:bodyPr/>
-          <a:lstStyle/>
-          <a:p>
+          <p:cNvPr id="19" name="Rectangle 18">
+            <a:extLst>
+              <a:ext uri="{FF2B5EF4-FFF2-40B4-BE49-F238E27FC236}">
+                <a16:creationId xmlns:a16="http://schemas.microsoft.com/office/drawing/2014/main" id="{1A9F23AD-7A55-49F3-A3EC-743F47F36B0E}"/>
+              </a:ext>
+              <a:ext uri="{C183D7F6-B498-43B3-948B-1728B52AA6E4}">
+                <adec:decorative xmlns:adec="http://schemas.microsoft.com/office/drawing/2017/decorative" val="1"/>
+              </a:ext>
+            </a:extLst>
+          </p:cNvPr>
+          <p:cNvSpPr>
+            <a:spLocks noGrp="1" noRot="1" noChangeAspect="1" noMove="1" noResize="1" noEditPoints="1" noAdjustHandles="1" noChangeArrowheads="1" noChangeShapeType="1" noTextEdit="1"/>
+          </p:cNvSpPr>
+          <p:nvPr>
+            <p:extLst>
+              <p:ext uri="{386F3935-93C4-4BCD-93E2-E3B085C9AB24}">
+                <p16:designElem xmlns:p16="http://schemas.microsoft.com/office/powerpoint/2015/main" val="1"/>
+              </p:ext>
+            </p:extLst>
+          </p:nvPr>
+        </p:nvSpPr>
+        <p:spPr>
+          <a:xfrm>
+            <a:off x="477012" y="487090"/>
+            <a:ext cx="6741849" cy="5897880"/>
+          </a:xfrm>
+          <a:prstGeom prst="rect">
+            <a:avLst/>
+          </a:prstGeom>
+          <a:solidFill>
+            <a:srgbClr val="FFFFFF"/>
+          </a:solidFill>
+          <a:ln w="19050">
+            <a:solidFill>
+              <a:schemeClr val="tx1">
+                <a:lumMod val="50000"/>
+                <a:lumOff val="50000"/>
+                <a:alpha val="80000"/>
+              </a:schemeClr>
+            </a:solidFill>
+          </a:ln>
+        </p:spPr>
+        <p:style>
+          <a:lnRef idx="2">
+            <a:schemeClr val="accent1">
+              <a:shade val="50000"/>
+            </a:schemeClr>
+          </a:lnRef>
+          <a:fillRef idx="1">
+            <a:schemeClr val="accent1"/>
+          </a:fillRef>
+          <a:effectRef idx="0">
+            <a:schemeClr val="accent1"/>
+          </a:effectRef>
+          <a:fontRef idx="minor">
+            <a:schemeClr val="lt1"/>
+          </a:fontRef>
+        </p:style>
+        <p:txBody>
+          <a:bodyPr rtlCol="0" anchor="ctr"/>
+          <a:lstStyle/>
+          <a:p>
+            <a:pPr algn="ctr"/>
             <a:endParaRPr lang="en-US"/>
           </a:p>
         </p:txBody>
       </p:sp>
+      <p:sp>
+        <p:nvSpPr>
+          <p:cNvPr id="21" name="Rectangle 20">
+            <a:extLst>
+              <a:ext uri="{FF2B5EF4-FFF2-40B4-BE49-F238E27FC236}">
+                <a16:creationId xmlns:a16="http://schemas.microsoft.com/office/drawing/2014/main" id="{D7D9F91F-72C9-4DB9-ABD0-A8180D8262D5}"/>
+              </a:ext>
+              <a:ext uri="{C183D7F6-B498-43B3-948B-1728B52AA6E4}">
+                <adec:decorative xmlns:adec="http://schemas.microsoft.com/office/drawing/2017/decorative" val="1"/>
+              </a:ext>
+            </a:extLst>
+          </p:cNvPr>
+          <p:cNvSpPr>
+            <a:spLocks noGrp="1" noRot="1" noChangeAspect="1" noMove="1" noResize="1" noEditPoints="1" noAdjustHandles="1" noChangeArrowheads="1" noChangeShapeType="1" noTextEdit="1"/>
+          </p:cNvSpPr>
+          <p:nvPr>
+            <p:extLst>
+              <p:ext uri="{386F3935-93C4-4BCD-93E2-E3B085C9AB24}">
+                <p16:designElem xmlns:p16="http://schemas.microsoft.com/office/powerpoint/2015/main" val="1"/>
+              </p:ext>
+            </p:extLst>
+          </p:nvPr>
+        </p:nvSpPr>
+        <p:spPr>
+          <a:xfrm>
+            <a:off x="7534655" y="480060"/>
+            <a:ext cx="4180332" cy="2788074"/>
+          </a:xfrm>
+          <a:prstGeom prst="rect">
+            <a:avLst/>
+          </a:prstGeom>
+          <a:solidFill>
+            <a:srgbClr val="FFFFFF"/>
+          </a:solidFill>
+          <a:ln w="19050">
+            <a:solidFill>
+              <a:schemeClr val="tx1">
+                <a:lumMod val="50000"/>
+                <a:lumOff val="50000"/>
+                <a:alpha val="80000"/>
+              </a:schemeClr>
+            </a:solidFill>
+          </a:ln>
+        </p:spPr>
+        <p:style>
+          <a:lnRef idx="2">
+            <a:schemeClr val="accent1">
+              <a:shade val="50000"/>
+            </a:schemeClr>
+          </a:lnRef>
+          <a:fillRef idx="1">
+            <a:schemeClr val="accent1"/>
+          </a:fillRef>
+          <a:effectRef idx="0">
+            <a:schemeClr val="accent1"/>
+          </a:effectRef>
+          <a:fontRef idx="minor">
+            <a:schemeClr val="lt1"/>
+          </a:fontRef>
+        </p:style>
+        <p:txBody>
+          <a:bodyPr rtlCol="0" anchor="ctr"/>
+          <a:lstStyle/>
+          <a:p>
+            <a:pPr algn="ctr"/>
+            <a:endParaRPr lang="en-US"/>
+          </a:p>
+        </p:txBody>
+      </p:sp>
+      <p:pic>
+        <p:nvPicPr>
+          <p:cNvPr id="10" name="Picture 9">
+            <a:extLst>
+              <a:ext uri="{FF2B5EF4-FFF2-40B4-BE49-F238E27FC236}">
+                <a16:creationId xmlns:a16="http://schemas.microsoft.com/office/drawing/2014/main" id="{A61A77AC-E262-D088-2070-9BB35B1E817B}"/>
+              </a:ext>
+            </a:extLst>
+          </p:cNvPr>
+          <p:cNvPicPr>
+            <a:picLocks noChangeAspect="1"/>
+          </p:cNvPicPr>
+          <p:nvPr/>
+        </p:nvPicPr>
+        <p:blipFill>
+          <a:blip r:embed="rId2"/>
+          <a:stretch>
+            <a:fillRect/>
+          </a:stretch>
+        </p:blipFill>
+        <p:spPr>
+          <a:xfrm>
+            <a:off x="851843" y="1687447"/>
+            <a:ext cx="5902392" cy="3497166"/>
+          </a:xfrm>
+          <a:prstGeom prst="rect">
+            <a:avLst/>
+          </a:prstGeom>
+        </p:spPr>
+      </p:pic>
+      <p:sp>
+        <p:nvSpPr>
+          <p:cNvPr id="23" name="Rectangle 22">
+            <a:extLst>
+              <a:ext uri="{FF2B5EF4-FFF2-40B4-BE49-F238E27FC236}">
+                <a16:creationId xmlns:a16="http://schemas.microsoft.com/office/drawing/2014/main" id="{BE016956-CE9F-4946-8834-A8BC3529D0F6}"/>
+              </a:ext>
+              <a:ext uri="{C183D7F6-B498-43B3-948B-1728B52AA6E4}">
+                <adec:decorative xmlns:adec="http://schemas.microsoft.com/office/drawing/2017/decorative" val="1"/>
+              </a:ext>
+            </a:extLst>
+          </p:cNvPr>
+          <p:cNvSpPr>
+            <a:spLocks noGrp="1" noRot="1" noChangeAspect="1" noMove="1" noResize="1" noEditPoints="1" noAdjustHandles="1" noChangeArrowheads="1" noChangeShapeType="1" noTextEdit="1"/>
+          </p:cNvSpPr>
+          <p:nvPr>
+            <p:extLst>
+              <p:ext uri="{386F3935-93C4-4BCD-93E2-E3B085C9AB24}">
+                <p16:designElem xmlns:p16="http://schemas.microsoft.com/office/powerpoint/2015/main" val="1"/>
+              </p:ext>
+            </p:extLst>
+          </p:nvPr>
+        </p:nvSpPr>
+        <p:spPr>
+          <a:xfrm>
+            <a:off x="7534655" y="3603670"/>
+            <a:ext cx="4180332" cy="2788074"/>
+          </a:xfrm>
+          <a:prstGeom prst="rect">
+            <a:avLst/>
+          </a:prstGeom>
+          <a:solidFill>
+            <a:srgbClr val="FFFFFF"/>
+          </a:solidFill>
+          <a:ln w="19050">
+            <a:solidFill>
+              <a:schemeClr val="tx1">
+                <a:lumMod val="50000"/>
+                <a:lumOff val="50000"/>
+                <a:alpha val="80000"/>
+              </a:schemeClr>
+            </a:solidFill>
+          </a:ln>
+        </p:spPr>
+        <p:style>
+          <a:lnRef idx="2">
+            <a:schemeClr val="accent1">
+              <a:shade val="50000"/>
+            </a:schemeClr>
+          </a:lnRef>
+          <a:fillRef idx="1">
+            <a:schemeClr val="accent1"/>
+          </a:fillRef>
+          <a:effectRef idx="0">
+            <a:schemeClr val="accent1"/>
+          </a:effectRef>
+          <a:fontRef idx="minor">
+            <a:schemeClr val="lt1"/>
+          </a:fontRef>
+        </p:style>
+        <p:txBody>
+          <a:bodyPr rtlCol="0" anchor="ctr"/>
+          <a:lstStyle/>
+          <a:p>
+            <a:pPr algn="ctr"/>
+            <a:endParaRPr lang="en-US"/>
+          </a:p>
+        </p:txBody>
+      </p:sp>
+      <p:pic>
+        <p:nvPicPr>
+          <p:cNvPr id="8" name="Picture 7">
+            <a:extLst>
+              <a:ext uri="{FF2B5EF4-FFF2-40B4-BE49-F238E27FC236}">
+                <a16:creationId xmlns:a16="http://schemas.microsoft.com/office/drawing/2014/main" id="{0C0A097E-1E28-0789-DBC0-0178C2410D8F}"/>
+              </a:ext>
+            </a:extLst>
+          </p:cNvPr>
+          <p:cNvPicPr>
+            <a:picLocks noChangeAspect="1"/>
+          </p:cNvPicPr>
+          <p:nvPr/>
+        </p:nvPicPr>
+        <p:blipFill>
+          <a:blip r:embed="rId3"/>
+          <a:stretch>
+            <a:fillRect/>
+          </a:stretch>
+        </p:blipFill>
+        <p:spPr>
+          <a:xfrm>
+            <a:off x="7695873" y="3841982"/>
+            <a:ext cx="3854945" cy="2284054"/>
+          </a:xfrm>
+          <a:prstGeom prst="rect">
+            <a:avLst/>
+          </a:prstGeom>
+        </p:spPr>
+      </p:pic>
+      <p:pic>
+        <p:nvPicPr>
+          <p:cNvPr id="12" name="Picture 11">
+            <a:extLst>
+              <a:ext uri="{FF2B5EF4-FFF2-40B4-BE49-F238E27FC236}">
+                <a16:creationId xmlns:a16="http://schemas.microsoft.com/office/drawing/2014/main" id="{6B7E2C1A-3DE8-6948-017E-4162C894A224}"/>
+              </a:ext>
+            </a:extLst>
+          </p:cNvPr>
+          <p:cNvPicPr>
+            <a:picLocks noChangeAspect="1"/>
+          </p:cNvPicPr>
+          <p:nvPr/>
+        </p:nvPicPr>
+        <p:blipFill>
+          <a:blip r:embed="rId4"/>
+          <a:stretch>
+            <a:fillRect/>
+          </a:stretch>
+        </p:blipFill>
+        <p:spPr>
+          <a:xfrm>
+            <a:off x="8008070" y="797627"/>
+            <a:ext cx="3124527" cy="2319961"/>
+          </a:xfrm>
+          <a:prstGeom prst="rect">
+            <a:avLst/>
+          </a:prstGeom>
+        </p:spPr>
+      </p:pic>
     </p:spTree>
     <p:extLst>
       <p:ext uri="{BB962C8B-B14F-4D97-AF65-F5344CB8AC3E}">
-        <p14:creationId xmlns:p14="http://schemas.microsoft.com/office/powerpoint/2010/main" val="1341886084"/>
+        <p14:creationId xmlns:p14="http://schemas.microsoft.com/office/powerpoint/2010/main" val="1653663860"/>
       </p:ext>
     </p:extLst>
   </p:cSld>
@@ -3565,12 +4493,42 @@
           <a:chExt cx="0" cy="0"/>
         </a:xfrm>
       </p:grpSpPr>
-      <p:sp>
-        <p:nvSpPr>
-          <p:cNvPr id="2" name="Title 1">
-            <a:extLst>
-              <a:ext uri="{FF2B5EF4-FFF2-40B4-BE49-F238E27FC236}">
-                <a16:creationId xmlns:a16="http://schemas.microsoft.com/office/drawing/2014/main" id="{44B5E3D5-6A34-F4BC-D40E-19DF4BE353E6}"/>
+      <p:pic>
+        <p:nvPicPr>
+          <p:cNvPr id="3" name="Picture 2">
+            <a:extLst>
+              <a:ext uri="{FF2B5EF4-FFF2-40B4-BE49-F238E27FC236}">
+                <a16:creationId xmlns:a16="http://schemas.microsoft.com/office/drawing/2014/main" id="{17C019E0-1ED9-A085-2297-80B0503E0DFB}"/>
+              </a:ext>
+            </a:extLst>
+          </p:cNvPr>
+          <p:cNvPicPr>
+            <a:picLocks noChangeAspect="1"/>
+          </p:cNvPicPr>
+          <p:nvPr/>
+        </p:nvPicPr>
+        <p:blipFill>
+          <a:blip r:embed="rId2"/>
+          <a:stretch>
+            <a:fillRect/>
+          </a:stretch>
+        </p:blipFill>
+        <p:spPr>
+          <a:xfrm>
+            <a:off x="308749" y="1948816"/>
+            <a:ext cx="11650701" cy="4544059"/>
+          </a:xfrm>
+          <a:prstGeom prst="rect">
+            <a:avLst/>
+          </a:prstGeom>
+        </p:spPr>
+      </p:pic>
+      <p:sp>
+        <p:nvSpPr>
+          <p:cNvPr id="4" name="Title 3">
+            <a:extLst>
+              <a:ext uri="{FF2B5EF4-FFF2-40B4-BE49-F238E27FC236}">
+                <a16:creationId xmlns:a16="http://schemas.microsoft.com/office/drawing/2014/main" id="{7D74FC06-3A9C-D63E-0226-2408C181BC5E}"/>
               </a:ext>
             </a:extLst>
           </p:cNvPr>
@@ -3586,39 +4544,17 @@
           <a:bodyPr/>
           <a:lstStyle/>
           <a:p>
-            <a:endParaRPr lang="en-US"/>
-          </a:p>
-        </p:txBody>
-      </p:sp>
-      <p:sp>
-        <p:nvSpPr>
-          <p:cNvPr id="3" name="Content Placeholder 2">
-            <a:extLst>
-              <a:ext uri="{FF2B5EF4-FFF2-40B4-BE49-F238E27FC236}">
-                <a16:creationId xmlns:a16="http://schemas.microsoft.com/office/drawing/2014/main" id="{119F5501-CD80-CA9B-AE8A-939EE41D7B1A}"/>
-              </a:ext>
-            </a:extLst>
-          </p:cNvPr>
-          <p:cNvSpPr>
-            <a:spLocks noGrp="1"/>
-          </p:cNvSpPr>
-          <p:nvPr>
-            <p:ph idx="1"/>
-          </p:nvPr>
-        </p:nvSpPr>
-        <p:spPr/>
-        <p:txBody>
-          <a:bodyPr/>
-          <a:lstStyle/>
-          <a:p>
-            <a:endParaRPr lang="en-US"/>
+            <a:r>
+              <a:rPr lang="en-US" dirty="0"/>
+              <a:t>Manufacturing Order</a:t>
+            </a:r>
           </a:p>
         </p:txBody>
       </p:sp>
     </p:spTree>
     <p:extLst>
       <p:ext uri="{BB962C8B-B14F-4D97-AF65-F5344CB8AC3E}">
-        <p14:creationId xmlns:p14="http://schemas.microsoft.com/office/powerpoint/2010/main" val="1712888095"/>
+        <p14:creationId xmlns:p14="http://schemas.microsoft.com/office/powerpoint/2010/main" val="1725980915"/>
       </p:ext>
     </p:extLst>
   </p:cSld>
@@ -3645,12 +4581,72 @@
           <a:chExt cx="0" cy="0"/>
         </a:xfrm>
       </p:grpSpPr>
-      <p:sp>
-        <p:nvSpPr>
-          <p:cNvPr id="2" name="Title 1">
-            <a:extLst>
-              <a:ext uri="{FF2B5EF4-FFF2-40B4-BE49-F238E27FC236}">
-                <a16:creationId xmlns:a16="http://schemas.microsoft.com/office/drawing/2014/main" id="{44B5E3D5-6A34-F4BC-D40E-19DF4BE353E6}"/>
+      <p:pic>
+        <p:nvPicPr>
+          <p:cNvPr id="4" name="Picture 3">
+            <a:extLst>
+              <a:ext uri="{FF2B5EF4-FFF2-40B4-BE49-F238E27FC236}">
+                <a16:creationId xmlns:a16="http://schemas.microsoft.com/office/drawing/2014/main" id="{2CA79999-9ED7-3279-ABA3-A0A1A281AD30}"/>
+              </a:ext>
+            </a:extLst>
+          </p:cNvPr>
+          <p:cNvPicPr>
+            <a:picLocks noChangeAspect="1"/>
+          </p:cNvPicPr>
+          <p:nvPr/>
+        </p:nvPicPr>
+        <p:blipFill>
+          <a:blip r:embed="rId2"/>
+          <a:stretch>
+            <a:fillRect/>
+          </a:stretch>
+        </p:blipFill>
+        <p:spPr>
+          <a:xfrm>
+            <a:off x="838200" y="1690688"/>
+            <a:ext cx="4829849" cy="4772691"/>
+          </a:xfrm>
+          <a:prstGeom prst="rect">
+            <a:avLst/>
+          </a:prstGeom>
+        </p:spPr>
+      </p:pic>
+      <p:pic>
+        <p:nvPicPr>
+          <p:cNvPr id="6" name="Picture 5">
+            <a:extLst>
+              <a:ext uri="{FF2B5EF4-FFF2-40B4-BE49-F238E27FC236}">
+                <a16:creationId xmlns:a16="http://schemas.microsoft.com/office/drawing/2014/main" id="{C362CC77-5766-BB38-E222-014568C07A5D}"/>
+              </a:ext>
+            </a:extLst>
+          </p:cNvPr>
+          <p:cNvPicPr>
+            <a:picLocks noChangeAspect="1"/>
+          </p:cNvPicPr>
+          <p:nvPr/>
+        </p:nvPicPr>
+        <p:blipFill>
+          <a:blip r:embed="rId3"/>
+          <a:stretch>
+            <a:fillRect/>
+          </a:stretch>
+        </p:blipFill>
+        <p:spPr>
+          <a:xfrm>
+            <a:off x="6960721" y="1690688"/>
+            <a:ext cx="4572638" cy="4544059"/>
+          </a:xfrm>
+          <a:prstGeom prst="rect">
+            <a:avLst/>
+          </a:prstGeom>
+        </p:spPr>
+      </p:pic>
+      <p:sp>
+        <p:nvSpPr>
+          <p:cNvPr id="9" name="Title 8">
+            <a:extLst>
+              <a:ext uri="{FF2B5EF4-FFF2-40B4-BE49-F238E27FC236}">
+                <a16:creationId xmlns:a16="http://schemas.microsoft.com/office/drawing/2014/main" id="{F41C995D-F6B0-6354-FFE2-77E28D3CEE8C}"/>
               </a:ext>
             </a:extLst>
           </p:cNvPr>
@@ -3666,39 +4662,17 @@
           <a:bodyPr/>
           <a:lstStyle/>
           <a:p>
-            <a:endParaRPr lang="en-US"/>
-          </a:p>
-        </p:txBody>
-      </p:sp>
-      <p:sp>
-        <p:nvSpPr>
-          <p:cNvPr id="3" name="Content Placeholder 2">
-            <a:extLst>
-              <a:ext uri="{FF2B5EF4-FFF2-40B4-BE49-F238E27FC236}">
-                <a16:creationId xmlns:a16="http://schemas.microsoft.com/office/drawing/2014/main" id="{119F5501-CD80-CA9B-AE8A-939EE41D7B1A}"/>
-              </a:ext>
-            </a:extLst>
-          </p:cNvPr>
-          <p:cNvSpPr>
-            <a:spLocks noGrp="1"/>
-          </p:cNvSpPr>
-          <p:nvPr>
-            <p:ph idx="1"/>
-          </p:nvPr>
-        </p:nvSpPr>
-        <p:spPr/>
-        <p:txBody>
-          <a:bodyPr/>
-          <a:lstStyle/>
-          <a:p>
-            <a:endParaRPr lang="en-US"/>
+            <a:r>
+              <a:rPr lang="en-US" dirty="0"/>
+              <a:t>Put Away Location</a:t>
+            </a:r>
           </a:p>
         </p:txBody>
       </p:sp>
     </p:spTree>
     <p:extLst>
       <p:ext uri="{BB962C8B-B14F-4D97-AF65-F5344CB8AC3E}">
-        <p14:creationId xmlns:p14="http://schemas.microsoft.com/office/powerpoint/2010/main" val="1472906487"/>
+        <p14:creationId xmlns:p14="http://schemas.microsoft.com/office/powerpoint/2010/main" val="4064084234"/>
       </p:ext>
     </p:extLst>
   </p:cSld>
@@ -3725,12 +4699,102 @@
           <a:chExt cx="0" cy="0"/>
         </a:xfrm>
       </p:grpSpPr>
-      <p:sp>
-        <p:nvSpPr>
-          <p:cNvPr id="2" name="Title 1">
-            <a:extLst>
-              <a:ext uri="{FF2B5EF4-FFF2-40B4-BE49-F238E27FC236}">
-                <a16:creationId xmlns:a16="http://schemas.microsoft.com/office/drawing/2014/main" id="{44B5E3D5-6A34-F4BC-D40E-19DF4BE353E6}"/>
+      <p:pic>
+        <p:nvPicPr>
+          <p:cNvPr id="7" name="Picture 6">
+            <a:extLst>
+              <a:ext uri="{FF2B5EF4-FFF2-40B4-BE49-F238E27FC236}">
+                <a16:creationId xmlns:a16="http://schemas.microsoft.com/office/drawing/2014/main" id="{CE72B0D3-FD5E-CFEF-0A20-926759EA6AB5}"/>
+              </a:ext>
+            </a:extLst>
+          </p:cNvPr>
+          <p:cNvPicPr>
+            <a:picLocks noChangeAspect="1"/>
+          </p:cNvPicPr>
+          <p:nvPr/>
+        </p:nvPicPr>
+        <p:blipFill>
+          <a:blip r:embed="rId2"/>
+          <a:stretch>
+            <a:fillRect/>
+          </a:stretch>
+        </p:blipFill>
+        <p:spPr>
+          <a:xfrm>
+            <a:off x="434588" y="2701031"/>
+            <a:ext cx="3591315" cy="1455938"/>
+          </a:xfrm>
+          <a:prstGeom prst="rect">
+            <a:avLst/>
+          </a:prstGeom>
+        </p:spPr>
+      </p:pic>
+      <p:pic>
+        <p:nvPicPr>
+          <p:cNvPr id="11" name="Picture 10">
+            <a:extLst>
+              <a:ext uri="{FF2B5EF4-FFF2-40B4-BE49-F238E27FC236}">
+                <a16:creationId xmlns:a16="http://schemas.microsoft.com/office/drawing/2014/main" id="{481429B6-069F-91A2-A63B-791C16DBAE15}"/>
+              </a:ext>
+            </a:extLst>
+          </p:cNvPr>
+          <p:cNvPicPr>
+            <a:picLocks noChangeAspect="1"/>
+          </p:cNvPicPr>
+          <p:nvPr/>
+        </p:nvPicPr>
+        <p:blipFill>
+          <a:blip r:embed="rId3"/>
+          <a:stretch>
+            <a:fillRect/>
+          </a:stretch>
+        </p:blipFill>
+        <p:spPr>
+          <a:xfrm>
+            <a:off x="4185853" y="2234154"/>
+            <a:ext cx="3500569" cy="2598800"/>
+          </a:xfrm>
+          <a:prstGeom prst="rect">
+            <a:avLst/>
+          </a:prstGeom>
+        </p:spPr>
+      </p:pic>
+      <p:pic>
+        <p:nvPicPr>
+          <p:cNvPr id="13" name="Picture 12">
+            <a:extLst>
+              <a:ext uri="{FF2B5EF4-FFF2-40B4-BE49-F238E27FC236}">
+                <a16:creationId xmlns:a16="http://schemas.microsoft.com/office/drawing/2014/main" id="{3E3FE982-05C2-2534-A63C-F19852D1DA59}"/>
+              </a:ext>
+            </a:extLst>
+          </p:cNvPr>
+          <p:cNvPicPr>
+            <a:picLocks noChangeAspect="1"/>
+          </p:cNvPicPr>
+          <p:nvPr/>
+        </p:nvPicPr>
+        <p:blipFill>
+          <a:blip r:embed="rId4"/>
+          <a:stretch>
+            <a:fillRect/>
+          </a:stretch>
+        </p:blipFill>
+        <p:spPr>
+          <a:xfrm>
+            <a:off x="7846372" y="753779"/>
+            <a:ext cx="4189076" cy="5552753"/>
+          </a:xfrm>
+          <a:prstGeom prst="rect">
+            <a:avLst/>
+          </a:prstGeom>
+        </p:spPr>
+      </p:pic>
+      <p:sp>
+        <p:nvSpPr>
+          <p:cNvPr id="14" name="Title 13">
+            <a:extLst>
+              <a:ext uri="{FF2B5EF4-FFF2-40B4-BE49-F238E27FC236}">
+                <a16:creationId xmlns:a16="http://schemas.microsoft.com/office/drawing/2014/main" id="{7F9AD821-9136-43E7-65A3-316A7456E78F}"/>
               </a:ext>
             </a:extLst>
           </p:cNvPr>
@@ -3746,39 +4810,64 @@
           <a:bodyPr/>
           <a:lstStyle/>
           <a:p>
-            <a:endParaRPr lang="en-US"/>
-          </a:p>
-        </p:txBody>
-      </p:sp>
-      <p:sp>
-        <p:nvSpPr>
-          <p:cNvPr id="3" name="Content Placeholder 2">
-            <a:extLst>
-              <a:ext uri="{FF2B5EF4-FFF2-40B4-BE49-F238E27FC236}">
-                <a16:creationId xmlns:a16="http://schemas.microsoft.com/office/drawing/2014/main" id="{119F5501-CD80-CA9B-AE8A-939EE41D7B1A}"/>
-              </a:ext>
-            </a:extLst>
-          </p:cNvPr>
-          <p:cNvSpPr>
-            <a:spLocks noGrp="1"/>
-          </p:cNvSpPr>
-          <p:nvPr>
-            <p:ph idx="1"/>
-          </p:nvPr>
-        </p:nvSpPr>
-        <p:spPr/>
-        <p:txBody>
-          <a:bodyPr/>
-          <a:lstStyle/>
-          <a:p>
-            <a:endParaRPr lang="en-US"/>
+            <a:r>
+              <a:rPr lang="vi-VN" b="0" i="0" dirty="0">
+                <a:solidFill>
+                  <a:srgbClr val="222222"/>
+                </a:solidFill>
+                <a:effectLst/>
+                <a:latin typeface="Lato" panose="020F0502020204030204" pitchFamily="34" charset="0"/>
+              </a:rPr>
+              <a:t>C</a:t>
+            </a:r>
+            <a:r>
+              <a:rPr lang="en-US" b="0" i="0" dirty="0" err="1">
+                <a:solidFill>
+                  <a:srgbClr val="222222"/>
+                </a:solidFill>
+                <a:effectLst/>
+                <a:latin typeface="Lato" panose="020F0502020204030204" pitchFamily="34" charset="0"/>
+              </a:rPr>
+              <a:t>ustom</a:t>
+            </a:r>
+            <a:r>
+              <a:rPr lang="en-US" b="0" i="0" dirty="0">
+                <a:solidFill>
+                  <a:srgbClr val="222222"/>
+                </a:solidFill>
+                <a:effectLst/>
+                <a:latin typeface="Lato" panose="020F0502020204030204" pitchFamily="34" charset="0"/>
+              </a:rPr>
+              <a:t> </a:t>
+            </a:r>
+            <a:r>
+              <a:rPr lang="vi-VN" b="0" i="0" dirty="0">
+                <a:solidFill>
+                  <a:srgbClr val="222222"/>
+                </a:solidFill>
+                <a:effectLst/>
+                <a:latin typeface="Lato" panose="020F0502020204030204" pitchFamily="34" charset="0"/>
+              </a:rPr>
+              <a:t>F</a:t>
+            </a:r>
+            <a:r>
+              <a:rPr lang="en-US" b="0" i="0" dirty="0" err="1">
+                <a:solidFill>
+                  <a:srgbClr val="222222"/>
+                </a:solidFill>
+                <a:effectLst/>
+                <a:latin typeface="Lato" panose="020F0502020204030204" pitchFamily="34" charset="0"/>
+              </a:rPr>
+              <a:t>ields</a:t>
+            </a:r>
+            <a:endParaRPr lang="en-US" dirty="0"/>
           </a:p>
         </p:txBody>
       </p:sp>
     </p:spTree>
     <p:extLst>
       <p:ext uri="{BB962C8B-B14F-4D97-AF65-F5344CB8AC3E}">
-        <p14:creationId xmlns:p14="http://schemas.microsoft.com/office/powerpoint/2010/main" val="1642819973"/>
+        <p14:creationId xmlns:p14="http://schemas.microsoft.com/office/powerpoint/2010/main" val="2845726448"/>
       </p:ext>
     </p:extLst>
   </p:cSld>
@@ -3807,10 +4896,10 @@
       </p:grpSpPr>
       <p:sp>
         <p:nvSpPr>
-          <p:cNvPr id="2" name="Title 1">
-            <a:extLst>
-              <a:ext uri="{FF2B5EF4-FFF2-40B4-BE49-F238E27FC236}">
-                <a16:creationId xmlns:a16="http://schemas.microsoft.com/office/drawing/2014/main" id="{44B5E3D5-6A34-F4BC-D40E-19DF4BE353E6}"/>
+          <p:cNvPr id="14" name="Title 13">
+            <a:extLst>
+              <a:ext uri="{FF2B5EF4-FFF2-40B4-BE49-F238E27FC236}">
+                <a16:creationId xmlns:a16="http://schemas.microsoft.com/office/drawing/2014/main" id="{7F9AD821-9136-43E7-65A3-316A7456E78F}"/>
               </a:ext>
             </a:extLst>
           </p:cNvPr>
@@ -3826,39 +4915,114 @@
           <a:bodyPr/>
           <a:lstStyle/>
           <a:p>
-            <a:endParaRPr lang="en-US"/>
-          </a:p>
-        </p:txBody>
-      </p:sp>
-      <p:sp>
-        <p:nvSpPr>
-          <p:cNvPr id="3" name="Content Placeholder 2">
-            <a:extLst>
-              <a:ext uri="{FF2B5EF4-FFF2-40B4-BE49-F238E27FC236}">
-                <a16:creationId xmlns:a16="http://schemas.microsoft.com/office/drawing/2014/main" id="{119F5501-CD80-CA9B-AE8A-939EE41D7B1A}"/>
-              </a:ext>
-            </a:extLst>
-          </p:cNvPr>
-          <p:cNvSpPr>
-            <a:spLocks noGrp="1"/>
-          </p:cNvSpPr>
-          <p:nvPr>
-            <p:ph idx="1"/>
-          </p:nvPr>
-        </p:nvSpPr>
-        <p:spPr/>
-        <p:txBody>
-          <a:bodyPr/>
-          <a:lstStyle/>
-          <a:p>
-            <a:endParaRPr lang="en-US"/>
-          </a:p>
-        </p:txBody>
-      </p:sp>
+            <a:r>
+              <a:rPr lang="en-US" b="0" i="0" dirty="0">
+                <a:solidFill>
+                  <a:srgbClr val="222222"/>
+                </a:solidFill>
+                <a:effectLst/>
+                <a:latin typeface="Lato" panose="020F0502020204030204" pitchFamily="34" charset="0"/>
+              </a:rPr>
+              <a:t>Materials</a:t>
+            </a:r>
+            <a:endParaRPr lang="en-US" dirty="0"/>
+          </a:p>
+        </p:txBody>
+      </p:sp>
+      <p:pic>
+        <p:nvPicPr>
+          <p:cNvPr id="3" name="Picture 2">
+            <a:extLst>
+              <a:ext uri="{FF2B5EF4-FFF2-40B4-BE49-F238E27FC236}">
+                <a16:creationId xmlns:a16="http://schemas.microsoft.com/office/drawing/2014/main" id="{20B43C2B-7945-03CC-8DC3-6C7D935C299B}"/>
+              </a:ext>
+            </a:extLst>
+          </p:cNvPr>
+          <p:cNvPicPr>
+            <a:picLocks noChangeAspect="1"/>
+          </p:cNvPicPr>
+          <p:nvPr/>
+        </p:nvPicPr>
+        <p:blipFill>
+          <a:blip r:embed="rId2"/>
+          <a:stretch>
+            <a:fillRect/>
+          </a:stretch>
+        </p:blipFill>
+        <p:spPr>
+          <a:xfrm>
+            <a:off x="596901" y="1690688"/>
+            <a:ext cx="3902856" cy="3234020"/>
+          </a:xfrm>
+          <a:prstGeom prst="rect">
+            <a:avLst/>
+          </a:prstGeom>
+        </p:spPr>
+      </p:pic>
+      <p:pic>
+        <p:nvPicPr>
+          <p:cNvPr id="5" name="Picture 4">
+            <a:extLst>
+              <a:ext uri="{FF2B5EF4-FFF2-40B4-BE49-F238E27FC236}">
+                <a16:creationId xmlns:a16="http://schemas.microsoft.com/office/drawing/2014/main" id="{A05D9D7F-42DD-C62A-9347-54E0A8B69A05}"/>
+              </a:ext>
+            </a:extLst>
+          </p:cNvPr>
+          <p:cNvPicPr>
+            <a:picLocks noChangeAspect="1"/>
+          </p:cNvPicPr>
+          <p:nvPr/>
+        </p:nvPicPr>
+        <p:blipFill>
+          <a:blip r:embed="rId3"/>
+          <a:stretch>
+            <a:fillRect/>
+          </a:stretch>
+        </p:blipFill>
+        <p:spPr>
+          <a:xfrm>
+            <a:off x="4846286" y="1690688"/>
+            <a:ext cx="3599214" cy="2735130"/>
+          </a:xfrm>
+          <a:prstGeom prst="rect">
+            <a:avLst/>
+          </a:prstGeom>
+        </p:spPr>
+      </p:pic>
+      <p:pic>
+        <p:nvPicPr>
+          <p:cNvPr id="8" name="Picture 7">
+            <a:extLst>
+              <a:ext uri="{FF2B5EF4-FFF2-40B4-BE49-F238E27FC236}">
+                <a16:creationId xmlns:a16="http://schemas.microsoft.com/office/drawing/2014/main" id="{BFF2A18B-BE1B-7AD6-3459-17316ED05427}"/>
+              </a:ext>
+            </a:extLst>
+          </p:cNvPr>
+          <p:cNvPicPr>
+            <a:picLocks noChangeAspect="1"/>
+          </p:cNvPicPr>
+          <p:nvPr/>
+        </p:nvPicPr>
+        <p:blipFill>
+          <a:blip r:embed="rId4"/>
+          <a:stretch>
+            <a:fillRect/>
+          </a:stretch>
+        </p:blipFill>
+        <p:spPr>
+          <a:xfrm>
+            <a:off x="8687567" y="1690688"/>
+            <a:ext cx="3212666" cy="3141987"/>
+          </a:xfrm>
+          <a:prstGeom prst="rect">
+            <a:avLst/>
+          </a:prstGeom>
+        </p:spPr>
+      </p:pic>
     </p:spTree>
     <p:extLst>
       <p:ext uri="{BB962C8B-B14F-4D97-AF65-F5344CB8AC3E}">
-        <p14:creationId xmlns:p14="http://schemas.microsoft.com/office/powerpoint/2010/main" val="516265655"/>
+        <p14:creationId xmlns:p14="http://schemas.microsoft.com/office/powerpoint/2010/main" val="1909400932"/>
       </p:ext>
     </p:extLst>
   </p:cSld>
@@ -3887,10 +5051,10 @@
       </p:grpSpPr>
       <p:sp>
         <p:nvSpPr>
-          <p:cNvPr id="2" name="Title 1">
-            <a:extLst>
-              <a:ext uri="{FF2B5EF4-FFF2-40B4-BE49-F238E27FC236}">
-                <a16:creationId xmlns:a16="http://schemas.microsoft.com/office/drawing/2014/main" id="{44B5E3D5-6A34-F4BC-D40E-19DF4BE353E6}"/>
+          <p:cNvPr id="14" name="Title 13">
+            <a:extLst>
+              <a:ext uri="{FF2B5EF4-FFF2-40B4-BE49-F238E27FC236}">
+                <a16:creationId xmlns:a16="http://schemas.microsoft.com/office/drawing/2014/main" id="{7F9AD821-9136-43E7-65A3-316A7456E78F}"/>
               </a:ext>
             </a:extLst>
           </p:cNvPr>
@@ -3906,39 +5070,54 @@
           <a:bodyPr/>
           <a:lstStyle/>
           <a:p>
-            <a:endParaRPr lang="en-US"/>
-          </a:p>
-        </p:txBody>
-      </p:sp>
-      <p:sp>
-        <p:nvSpPr>
-          <p:cNvPr id="3" name="Content Placeholder 2">
-            <a:extLst>
-              <a:ext uri="{FF2B5EF4-FFF2-40B4-BE49-F238E27FC236}">
-                <a16:creationId xmlns:a16="http://schemas.microsoft.com/office/drawing/2014/main" id="{119F5501-CD80-CA9B-AE8A-939EE41D7B1A}"/>
-              </a:ext>
-            </a:extLst>
-          </p:cNvPr>
-          <p:cNvSpPr>
-            <a:spLocks noGrp="1"/>
-          </p:cNvSpPr>
-          <p:nvPr>
-            <p:ph idx="1"/>
-          </p:nvPr>
-        </p:nvSpPr>
-        <p:spPr/>
-        <p:txBody>
-          <a:bodyPr/>
-          <a:lstStyle/>
-          <a:p>
-            <a:endParaRPr lang="en-US"/>
-          </a:p>
-        </p:txBody>
-      </p:sp>
+            <a:r>
+              <a:rPr lang="en-US" b="0" i="0" dirty="0">
+                <a:solidFill>
+                  <a:srgbClr val="222222"/>
+                </a:solidFill>
+                <a:effectLst/>
+                <a:latin typeface="Lato" panose="020F0502020204030204" pitchFamily="34" charset="0"/>
+              </a:rPr>
+              <a:t>Materials</a:t>
+            </a:r>
+            <a:endParaRPr lang="en-US" dirty="0"/>
+          </a:p>
+        </p:txBody>
+      </p:sp>
+      <p:pic>
+        <p:nvPicPr>
+          <p:cNvPr id="4" name="Picture 3">
+            <a:extLst>
+              <a:ext uri="{FF2B5EF4-FFF2-40B4-BE49-F238E27FC236}">
+                <a16:creationId xmlns:a16="http://schemas.microsoft.com/office/drawing/2014/main" id="{EE2BDAB4-0CD4-9BD5-5C2B-F73F475F2524}"/>
+              </a:ext>
+            </a:extLst>
+          </p:cNvPr>
+          <p:cNvPicPr>
+            <a:picLocks noChangeAspect="1"/>
+          </p:cNvPicPr>
+          <p:nvPr/>
+        </p:nvPicPr>
+        <p:blipFill>
+          <a:blip r:embed="rId2"/>
+          <a:stretch>
+            <a:fillRect/>
+          </a:stretch>
+        </p:blipFill>
+        <p:spPr>
+          <a:xfrm>
+            <a:off x="8327484" y="1346200"/>
+            <a:ext cx="2515376" cy="4965700"/>
+          </a:xfrm>
+          <a:prstGeom prst="rect">
+            <a:avLst/>
+          </a:prstGeom>
+        </p:spPr>
+      </p:pic>
     </p:spTree>
     <p:extLst>
       <p:ext uri="{BB962C8B-B14F-4D97-AF65-F5344CB8AC3E}">
-        <p14:creationId xmlns:p14="http://schemas.microsoft.com/office/powerpoint/2010/main" val="1496040693"/>
+        <p14:creationId xmlns:p14="http://schemas.microsoft.com/office/powerpoint/2010/main" val="804896256"/>
       </p:ext>
     </p:extLst>
   </p:cSld>
@@ -3967,10 +5146,10 @@
       </p:grpSpPr>
       <p:sp>
         <p:nvSpPr>
-          <p:cNvPr id="2" name="Title 1">
-            <a:extLst>
-              <a:ext uri="{FF2B5EF4-FFF2-40B4-BE49-F238E27FC236}">
-                <a16:creationId xmlns:a16="http://schemas.microsoft.com/office/drawing/2014/main" id="{44B5E3D5-6A34-F4BC-D40E-19DF4BE353E6}"/>
+          <p:cNvPr id="14" name="Title 13">
+            <a:extLst>
+              <a:ext uri="{FF2B5EF4-FFF2-40B4-BE49-F238E27FC236}">
+                <a16:creationId xmlns:a16="http://schemas.microsoft.com/office/drawing/2014/main" id="{7F9AD821-9136-43E7-65A3-316A7456E78F}"/>
               </a:ext>
             </a:extLst>
           </p:cNvPr>
@@ -3986,39 +5165,54 @@
           <a:bodyPr/>
           <a:lstStyle/>
           <a:p>
-            <a:endParaRPr lang="en-US"/>
-          </a:p>
-        </p:txBody>
-      </p:sp>
-      <p:sp>
-        <p:nvSpPr>
-          <p:cNvPr id="3" name="Content Placeholder 2">
-            <a:extLst>
-              <a:ext uri="{FF2B5EF4-FFF2-40B4-BE49-F238E27FC236}">
-                <a16:creationId xmlns:a16="http://schemas.microsoft.com/office/drawing/2014/main" id="{119F5501-CD80-CA9B-AE8A-939EE41D7B1A}"/>
-              </a:ext>
-            </a:extLst>
-          </p:cNvPr>
-          <p:cNvSpPr>
-            <a:spLocks noGrp="1"/>
-          </p:cNvSpPr>
-          <p:nvPr>
-            <p:ph idx="1"/>
-          </p:nvPr>
-        </p:nvSpPr>
-        <p:spPr/>
-        <p:txBody>
-          <a:bodyPr/>
-          <a:lstStyle/>
-          <a:p>
-            <a:endParaRPr lang="en-US"/>
-          </a:p>
-        </p:txBody>
-      </p:sp>
+            <a:r>
+              <a:rPr lang="en-US" b="0" i="0" u="none" strike="noStrike" dirty="0">
+                <a:solidFill>
+                  <a:srgbClr val="58698D"/>
+                </a:solidFill>
+                <a:effectLst/>
+                <a:latin typeface="Lato" panose="020F0502020204030203" pitchFamily="34" charset="0"/>
+              </a:rPr>
+              <a:t>Operation type</a:t>
+            </a:r>
+            <a:endParaRPr lang="en-US" dirty="0"/>
+          </a:p>
+        </p:txBody>
+      </p:sp>
+      <p:pic>
+        <p:nvPicPr>
+          <p:cNvPr id="3" name="Picture 2">
+            <a:extLst>
+              <a:ext uri="{FF2B5EF4-FFF2-40B4-BE49-F238E27FC236}">
+                <a16:creationId xmlns:a16="http://schemas.microsoft.com/office/drawing/2014/main" id="{4E652CA9-9265-D71F-FE29-6C809DC8BCB4}"/>
+              </a:ext>
+            </a:extLst>
+          </p:cNvPr>
+          <p:cNvPicPr>
+            <a:picLocks noChangeAspect="1"/>
+          </p:cNvPicPr>
+          <p:nvPr/>
+        </p:nvPicPr>
+        <p:blipFill>
+          <a:blip r:embed="rId2"/>
+          <a:stretch>
+            <a:fillRect/>
+          </a:stretch>
+        </p:blipFill>
+        <p:spPr>
+          <a:xfrm>
+            <a:off x="838200" y="1509386"/>
+            <a:ext cx="4639322" cy="4677428"/>
+          </a:xfrm>
+          <a:prstGeom prst="rect">
+            <a:avLst/>
+          </a:prstGeom>
+        </p:spPr>
+      </p:pic>
     </p:spTree>
     <p:extLst>
       <p:ext uri="{BB962C8B-B14F-4D97-AF65-F5344CB8AC3E}">
-        <p14:creationId xmlns:p14="http://schemas.microsoft.com/office/powerpoint/2010/main" val="1499728541"/>
+        <p14:creationId xmlns:p14="http://schemas.microsoft.com/office/powerpoint/2010/main" val="1465373130"/>
       </p:ext>
     </p:extLst>
   </p:cSld>

</xml_diff>